<commit_message>
Added Assessment practices artifact
Updated project presentation
</commit_message>
<xml_diff>
--- a/artifacts/III-FinalPresentation & Cell Phone Project/Final Presentation.pptx
+++ b/artifacts/III-FinalPresentation & Cell Phone Project/Final Presentation.pptx
@@ -5,26 +5,27 @@
     <p:sldMasterId id="2147483698" r:id="rId1"/>
   </p:sldMasterIdLst>
   <p:notesMasterIdLst>
-    <p:notesMasterId r:id="rId19"/>
+    <p:notesMasterId r:id="rId20"/>
   </p:notesMasterIdLst>
   <p:sldIdLst>
     <p:sldId id="256" r:id="rId2"/>
     <p:sldId id="267" r:id="rId3"/>
-    <p:sldId id="268" r:id="rId4"/>
-    <p:sldId id="269" r:id="rId5"/>
-    <p:sldId id="270" r:id="rId6"/>
-    <p:sldId id="271" r:id="rId7"/>
-    <p:sldId id="272" r:id="rId8"/>
-    <p:sldId id="273" r:id="rId9"/>
-    <p:sldId id="258" r:id="rId10"/>
-    <p:sldId id="259" r:id="rId11"/>
-    <p:sldId id="260" r:id="rId12"/>
-    <p:sldId id="261" r:id="rId13"/>
-    <p:sldId id="262" r:id="rId14"/>
-    <p:sldId id="263" r:id="rId15"/>
-    <p:sldId id="264" r:id="rId16"/>
-    <p:sldId id="265" r:id="rId17"/>
-    <p:sldId id="266" r:id="rId18"/>
+    <p:sldId id="274" r:id="rId4"/>
+    <p:sldId id="268" r:id="rId5"/>
+    <p:sldId id="269" r:id="rId6"/>
+    <p:sldId id="270" r:id="rId7"/>
+    <p:sldId id="271" r:id="rId8"/>
+    <p:sldId id="272" r:id="rId9"/>
+    <p:sldId id="273" r:id="rId10"/>
+    <p:sldId id="258" r:id="rId11"/>
+    <p:sldId id="259" r:id="rId12"/>
+    <p:sldId id="260" r:id="rId13"/>
+    <p:sldId id="261" r:id="rId14"/>
+    <p:sldId id="262" r:id="rId15"/>
+    <p:sldId id="263" r:id="rId16"/>
+    <p:sldId id="264" r:id="rId17"/>
+    <p:sldId id="265" r:id="rId18"/>
+    <p:sldId id="266" r:id="rId19"/>
   </p:sldIdLst>
   <p:sldSz cx="12192000" cy="6858000"/>
   <p:notesSz cx="6858000" cy="9144000"/>
@@ -638,7 +639,7 @@
     </p:spTree>
     <p:extLst>
       <p:ext uri="{BB962C8B-B14F-4D97-AF65-F5344CB8AC3E}">
-        <p14:creationId xmlns:p14="http://schemas.microsoft.com/office/powerpoint/2010/main" val="3044426469"/>
+        <p14:creationId xmlns:p14="http://schemas.microsoft.com/office/powerpoint/2010/main" val="3960314971"/>
       </p:ext>
     </p:extLst>
   </p:cSld>
@@ -714,6 +715,90 @@
             <a:fld id="{49EAD848-1BB2-E142-92F4-A86EECDCA8FE}" type="slidenum">
               <a:rPr lang="en-US" smtClean="0"/>
               <a:t>11</a:t>
+            </a:fld>
+            <a:endParaRPr lang="en-US"/>
+          </a:p>
+        </p:txBody>
+      </p:sp>
+    </p:spTree>
+    <p:extLst>
+      <p:ext uri="{BB962C8B-B14F-4D97-AF65-F5344CB8AC3E}">
+        <p14:creationId xmlns:p14="http://schemas.microsoft.com/office/powerpoint/2010/main" val="3044426469"/>
+      </p:ext>
+    </p:extLst>
+  </p:cSld>
+  <p:clrMapOvr>
+    <a:masterClrMapping/>
+  </p:clrMapOvr>
+</p:notes>
+</file>
+
+<file path=ppt/notesSlides/notesSlide12.xml><?xml version="1.0" encoding="utf-8"?>
+<p:notes xmlns:a="http://schemas.openxmlformats.org/drawingml/2006/main" xmlns:r="http://schemas.openxmlformats.org/officeDocument/2006/relationships" xmlns:p="http://schemas.openxmlformats.org/presentationml/2006/main">
+  <p:cSld>
+    <p:spTree>
+      <p:nvGrpSpPr>
+        <p:cNvPr id="1" name=""/>
+        <p:cNvGrpSpPr/>
+        <p:nvPr/>
+      </p:nvGrpSpPr>
+      <p:grpSpPr>
+        <a:xfrm>
+          <a:off x="0" y="0"/>
+          <a:ext cx="0" cy="0"/>
+          <a:chOff x="0" y="0"/>
+          <a:chExt cx="0" cy="0"/>
+        </a:xfrm>
+      </p:grpSpPr>
+      <p:sp>
+        <p:nvSpPr>
+          <p:cNvPr id="2" name="Slide Image Placeholder 1"/>
+          <p:cNvSpPr>
+            <a:spLocks noGrp="1" noRot="1" noChangeAspect="1"/>
+          </p:cNvSpPr>
+          <p:nvPr>
+            <p:ph type="sldImg"/>
+          </p:nvPr>
+        </p:nvSpPr>
+        <p:spPr/>
+      </p:sp>
+      <p:sp>
+        <p:nvSpPr>
+          <p:cNvPr id="3" name="Notes Placeholder 2"/>
+          <p:cNvSpPr>
+            <a:spLocks noGrp="1"/>
+          </p:cNvSpPr>
+          <p:nvPr>
+            <p:ph type="body" idx="1"/>
+          </p:nvPr>
+        </p:nvSpPr>
+        <p:spPr/>
+        <p:txBody>
+          <a:bodyPr/>
+          <a:lstStyle/>
+          <a:p>
+            <a:endParaRPr lang="en-US"/>
+          </a:p>
+        </p:txBody>
+      </p:sp>
+      <p:sp>
+        <p:nvSpPr>
+          <p:cNvPr id="4" name="Slide Number Placeholder 3"/>
+          <p:cNvSpPr>
+            <a:spLocks noGrp="1"/>
+          </p:cNvSpPr>
+          <p:nvPr>
+            <p:ph type="sldNum" sz="quarter" idx="5"/>
+          </p:nvPr>
+        </p:nvSpPr>
+        <p:spPr/>
+        <p:txBody>
+          <a:bodyPr/>
+          <a:lstStyle/>
+          <a:p>
+            <a:fld id="{49EAD848-1BB2-E142-92F4-A86EECDCA8FE}" type="slidenum">
+              <a:rPr lang="en-US" smtClean="0"/>
+              <a:t>12</a:t>
             </a:fld>
             <a:endParaRPr lang="en-US"/>
           </a:p>
@@ -890,7 +975,7 @@
     </p:spTree>
     <p:extLst>
       <p:ext uri="{BB962C8B-B14F-4D97-AF65-F5344CB8AC3E}">
-        <p14:creationId xmlns:p14="http://schemas.microsoft.com/office/powerpoint/2010/main" val="1071620346"/>
+        <p14:creationId xmlns:p14="http://schemas.microsoft.com/office/powerpoint/2010/main" val="3003269237"/>
       </p:ext>
     </p:extLst>
   </p:cSld>
@@ -974,7 +1059,7 @@
     </p:spTree>
     <p:extLst>
       <p:ext uri="{BB962C8B-B14F-4D97-AF65-F5344CB8AC3E}">
-        <p14:creationId xmlns:p14="http://schemas.microsoft.com/office/powerpoint/2010/main" val="326812665"/>
+        <p14:creationId xmlns:p14="http://schemas.microsoft.com/office/powerpoint/2010/main" val="1071620346"/>
       </p:ext>
     </p:extLst>
   </p:cSld>
@@ -1058,7 +1143,7 @@
     </p:spTree>
     <p:extLst>
       <p:ext uri="{BB962C8B-B14F-4D97-AF65-F5344CB8AC3E}">
-        <p14:creationId xmlns:p14="http://schemas.microsoft.com/office/powerpoint/2010/main" val="3968916726"/>
+        <p14:creationId xmlns:p14="http://schemas.microsoft.com/office/powerpoint/2010/main" val="326812665"/>
       </p:ext>
     </p:extLst>
   </p:cSld>
@@ -1142,7 +1227,7 @@
     </p:spTree>
     <p:extLst>
       <p:ext uri="{BB962C8B-B14F-4D97-AF65-F5344CB8AC3E}">
-        <p14:creationId xmlns:p14="http://schemas.microsoft.com/office/powerpoint/2010/main" val="673164573"/>
+        <p14:creationId xmlns:p14="http://schemas.microsoft.com/office/powerpoint/2010/main" val="3968916726"/>
       </p:ext>
     </p:extLst>
   </p:cSld>
@@ -1226,7 +1311,7 @@
     </p:spTree>
     <p:extLst>
       <p:ext uri="{BB962C8B-B14F-4D97-AF65-F5344CB8AC3E}">
-        <p14:creationId xmlns:p14="http://schemas.microsoft.com/office/powerpoint/2010/main" val="2684819864"/>
+        <p14:creationId xmlns:p14="http://schemas.microsoft.com/office/powerpoint/2010/main" val="673164573"/>
       </p:ext>
     </p:extLst>
   </p:cSld>
@@ -1310,7 +1395,7 @@
     </p:spTree>
     <p:extLst>
       <p:ext uri="{BB962C8B-B14F-4D97-AF65-F5344CB8AC3E}">
-        <p14:creationId xmlns:p14="http://schemas.microsoft.com/office/powerpoint/2010/main" val="2115632976"/>
+        <p14:creationId xmlns:p14="http://schemas.microsoft.com/office/powerpoint/2010/main" val="2684819864"/>
       </p:ext>
     </p:extLst>
   </p:cSld>
@@ -1394,7 +1479,7 @@
     </p:spTree>
     <p:extLst>
       <p:ext uri="{BB962C8B-B14F-4D97-AF65-F5344CB8AC3E}">
-        <p14:creationId xmlns:p14="http://schemas.microsoft.com/office/powerpoint/2010/main" val="3960314971"/>
+        <p14:creationId xmlns:p14="http://schemas.microsoft.com/office/powerpoint/2010/main" val="2115632976"/>
       </p:ext>
     </p:extLst>
   </p:cSld>
@@ -5084,7 +5169,7 @@
           <p:cNvPr id="2" name="Title 1">
             <a:extLst>
               <a:ext uri="{FF2B5EF4-FFF2-40B4-BE49-F238E27FC236}">
-                <a16:creationId xmlns:a16="http://schemas.microsoft.com/office/drawing/2014/main" id="{1AEACF71-D2D7-40DE-D418-C1ECF96EAC44}"/>
+                <a16:creationId xmlns:a16="http://schemas.microsoft.com/office/drawing/2014/main" id="{E969534C-CACF-5359-A628-373C2B981F33}"/>
               </a:ext>
             </a:extLst>
           </p:cNvPr>
@@ -5102,7 +5187,7 @@
           <a:p>
             <a:r>
               <a:rPr lang="en-US" dirty="0"/>
-              <a:t>Policies across schools</a:t>
+              <a:t>The Issue</a:t>
             </a:r>
           </a:p>
         </p:txBody>
@@ -5112,7 +5197,7 @@
           <p:cNvPr id="3" name="Text Placeholder 2">
             <a:extLst>
               <a:ext uri="{FF2B5EF4-FFF2-40B4-BE49-F238E27FC236}">
-                <a16:creationId xmlns:a16="http://schemas.microsoft.com/office/drawing/2014/main" id="{230B0D8C-28A0-A3F0-DF37-4BD1D9918D61}"/>
+                <a16:creationId xmlns:a16="http://schemas.microsoft.com/office/drawing/2014/main" id="{7C1838AA-32EF-5619-0D4F-E448665BCF5B}"/>
               </a:ext>
             </a:extLst>
           </p:cNvPr>
@@ -5135,7 +5220,7 @@
     </p:spTree>
     <p:extLst>
       <p:ext uri="{BB962C8B-B14F-4D97-AF65-F5344CB8AC3E}">
-        <p14:creationId xmlns:p14="http://schemas.microsoft.com/office/powerpoint/2010/main" val="3181300478"/>
+        <p14:creationId xmlns:p14="http://schemas.microsoft.com/office/powerpoint/2010/main" val="2798690559"/>
       </p:ext>
     </p:extLst>
   </p:cSld>
@@ -5167,7 +5252,7 @@
           <p:cNvPr id="2" name="Title 1">
             <a:extLst>
               <a:ext uri="{FF2B5EF4-FFF2-40B4-BE49-F238E27FC236}">
-                <a16:creationId xmlns:a16="http://schemas.microsoft.com/office/drawing/2014/main" id="{EB47CAA8-9BF1-40DF-503E-C54DAB75DB0A}"/>
+                <a16:creationId xmlns:a16="http://schemas.microsoft.com/office/drawing/2014/main" id="{1AEACF71-D2D7-40DE-D418-C1ECF96EAC44}"/>
               </a:ext>
             </a:extLst>
           </p:cNvPr>
@@ -5185,7 +5270,7 @@
           <a:p>
             <a:r>
               <a:rPr lang="en-US" dirty="0"/>
-              <a:t>At my school</a:t>
+              <a:t>Policies across schools</a:t>
             </a:r>
           </a:p>
         </p:txBody>
@@ -5195,7 +5280,7 @@
           <p:cNvPr id="3" name="Text Placeholder 2">
             <a:extLst>
               <a:ext uri="{FF2B5EF4-FFF2-40B4-BE49-F238E27FC236}">
-                <a16:creationId xmlns:a16="http://schemas.microsoft.com/office/drawing/2014/main" id="{7D9A9D03-013E-8DBC-A0FF-0D2591432C6F}"/>
+                <a16:creationId xmlns:a16="http://schemas.microsoft.com/office/drawing/2014/main" id="{230B0D8C-28A0-A3F0-DF37-4BD1D9918D61}"/>
               </a:ext>
             </a:extLst>
           </p:cNvPr>
@@ -5218,7 +5303,7 @@
     </p:spTree>
     <p:extLst>
       <p:ext uri="{BB962C8B-B14F-4D97-AF65-F5344CB8AC3E}">
-        <p14:creationId xmlns:p14="http://schemas.microsoft.com/office/powerpoint/2010/main" val="3770000959"/>
+        <p14:creationId xmlns:p14="http://schemas.microsoft.com/office/powerpoint/2010/main" val="3181300478"/>
       </p:ext>
     </p:extLst>
   </p:cSld>
@@ -5250,7 +5335,7 @@
           <p:cNvPr id="2" name="Title 1">
             <a:extLst>
               <a:ext uri="{FF2B5EF4-FFF2-40B4-BE49-F238E27FC236}">
-                <a16:creationId xmlns:a16="http://schemas.microsoft.com/office/drawing/2014/main" id="{F91BC558-303A-99B7-7131-5D927AC80DDD}"/>
+                <a16:creationId xmlns:a16="http://schemas.microsoft.com/office/drawing/2014/main" id="{EB47CAA8-9BF1-40DF-503E-C54DAB75DB0A}"/>
               </a:ext>
             </a:extLst>
           </p:cNvPr>
@@ -5268,7 +5353,7 @@
           <a:p>
             <a:r>
               <a:rPr lang="en-US" dirty="0"/>
-              <a:t>Initial phone survey</a:t>
+              <a:t>At my school</a:t>
             </a:r>
           </a:p>
         </p:txBody>
@@ -5278,7 +5363,7 @@
           <p:cNvPr id="3" name="Text Placeholder 2">
             <a:extLst>
               <a:ext uri="{FF2B5EF4-FFF2-40B4-BE49-F238E27FC236}">
-                <a16:creationId xmlns:a16="http://schemas.microsoft.com/office/drawing/2014/main" id="{D029876F-B799-5001-FBC9-290722710C64}"/>
+                <a16:creationId xmlns:a16="http://schemas.microsoft.com/office/drawing/2014/main" id="{7D9A9D03-013E-8DBC-A0FF-0D2591432C6F}"/>
               </a:ext>
             </a:extLst>
           </p:cNvPr>
@@ -5301,7 +5386,7 @@
     </p:spTree>
     <p:extLst>
       <p:ext uri="{BB962C8B-B14F-4D97-AF65-F5344CB8AC3E}">
-        <p14:creationId xmlns:p14="http://schemas.microsoft.com/office/powerpoint/2010/main" val="2161786268"/>
+        <p14:creationId xmlns:p14="http://schemas.microsoft.com/office/powerpoint/2010/main" val="3770000959"/>
       </p:ext>
     </p:extLst>
   </p:cSld>
@@ -5333,7 +5418,7 @@
           <p:cNvPr id="2" name="Title 1">
             <a:extLst>
               <a:ext uri="{FF2B5EF4-FFF2-40B4-BE49-F238E27FC236}">
-                <a16:creationId xmlns:a16="http://schemas.microsoft.com/office/drawing/2014/main" id="{55B7D94D-873B-32FA-35FA-346B72AA9C3A}"/>
+                <a16:creationId xmlns:a16="http://schemas.microsoft.com/office/drawing/2014/main" id="{F91BC558-303A-99B7-7131-5D927AC80DDD}"/>
               </a:ext>
             </a:extLst>
           </p:cNvPr>
@@ -5351,7 +5436,7 @@
           <a:p>
             <a:r>
               <a:rPr lang="en-US" dirty="0"/>
-              <a:t>Survey results alignment with academic studies</a:t>
+              <a:t>Initial phone survey</a:t>
             </a:r>
           </a:p>
         </p:txBody>
@@ -5361,7 +5446,7 @@
           <p:cNvPr id="3" name="Text Placeholder 2">
             <a:extLst>
               <a:ext uri="{FF2B5EF4-FFF2-40B4-BE49-F238E27FC236}">
-                <a16:creationId xmlns:a16="http://schemas.microsoft.com/office/drawing/2014/main" id="{91B5462E-37B8-C6B2-E13B-3A517B16FF7A}"/>
+                <a16:creationId xmlns:a16="http://schemas.microsoft.com/office/drawing/2014/main" id="{D029876F-B799-5001-FBC9-290722710C64}"/>
               </a:ext>
             </a:extLst>
           </p:cNvPr>
@@ -5384,7 +5469,7 @@
     </p:spTree>
     <p:extLst>
       <p:ext uri="{BB962C8B-B14F-4D97-AF65-F5344CB8AC3E}">
-        <p14:creationId xmlns:p14="http://schemas.microsoft.com/office/powerpoint/2010/main" val="1440451537"/>
+        <p14:creationId xmlns:p14="http://schemas.microsoft.com/office/powerpoint/2010/main" val="2161786268"/>
       </p:ext>
     </p:extLst>
   </p:cSld>
@@ -5416,7 +5501,7 @@
           <p:cNvPr id="2" name="Title 1">
             <a:extLst>
               <a:ext uri="{FF2B5EF4-FFF2-40B4-BE49-F238E27FC236}">
-                <a16:creationId xmlns:a16="http://schemas.microsoft.com/office/drawing/2014/main" id="{50821D30-3232-1A58-9C2C-35A34CF7574A}"/>
+                <a16:creationId xmlns:a16="http://schemas.microsoft.com/office/drawing/2014/main" id="{55B7D94D-873B-32FA-35FA-346B72AA9C3A}"/>
               </a:ext>
             </a:extLst>
           </p:cNvPr>
@@ -5434,7 +5519,7 @@
           <a:p>
             <a:r>
               <a:rPr lang="en-US" dirty="0"/>
-              <a:t>About  The School's new cell phone policy</a:t>
+              <a:t>Survey results alignment with academic studies</a:t>
             </a:r>
           </a:p>
         </p:txBody>
@@ -5444,7 +5529,7 @@
           <p:cNvPr id="3" name="Text Placeholder 2">
             <a:extLst>
               <a:ext uri="{FF2B5EF4-FFF2-40B4-BE49-F238E27FC236}">
-                <a16:creationId xmlns:a16="http://schemas.microsoft.com/office/drawing/2014/main" id="{CCDDB907-03E9-CEB2-E4EA-80D4ADD61856}"/>
+                <a16:creationId xmlns:a16="http://schemas.microsoft.com/office/drawing/2014/main" id="{91B5462E-37B8-C6B2-E13B-3A517B16FF7A}"/>
               </a:ext>
             </a:extLst>
           </p:cNvPr>
@@ -5467,7 +5552,7 @@
     </p:spTree>
     <p:extLst>
       <p:ext uri="{BB962C8B-B14F-4D97-AF65-F5344CB8AC3E}">
-        <p14:creationId xmlns:p14="http://schemas.microsoft.com/office/powerpoint/2010/main" val="3708357663"/>
+        <p14:creationId xmlns:p14="http://schemas.microsoft.com/office/powerpoint/2010/main" val="1440451537"/>
       </p:ext>
     </p:extLst>
   </p:cSld>
@@ -5499,7 +5584,7 @@
           <p:cNvPr id="2" name="Title 1">
             <a:extLst>
               <a:ext uri="{FF2B5EF4-FFF2-40B4-BE49-F238E27FC236}">
-                <a16:creationId xmlns:a16="http://schemas.microsoft.com/office/drawing/2014/main" id="{D5364C91-0B81-E09B-3D40-550B812C0936}"/>
+                <a16:creationId xmlns:a16="http://schemas.microsoft.com/office/drawing/2014/main" id="{50821D30-3232-1A58-9C2C-35A34CF7574A}"/>
               </a:ext>
             </a:extLst>
           </p:cNvPr>
@@ -5517,7 +5602,7 @@
           <a:p>
             <a:r>
               <a:rPr lang="en-US" dirty="0"/>
-              <a:t>Impact of  the new policy</a:t>
+              <a:t>About  The School's new cell phone policy</a:t>
             </a:r>
           </a:p>
         </p:txBody>
@@ -5527,7 +5612,7 @@
           <p:cNvPr id="3" name="Text Placeholder 2">
             <a:extLst>
               <a:ext uri="{FF2B5EF4-FFF2-40B4-BE49-F238E27FC236}">
-                <a16:creationId xmlns:a16="http://schemas.microsoft.com/office/drawing/2014/main" id="{BF1270A0-C891-F5EF-8144-0DA28B80CF05}"/>
+                <a16:creationId xmlns:a16="http://schemas.microsoft.com/office/drawing/2014/main" id="{CCDDB907-03E9-CEB2-E4EA-80D4ADD61856}"/>
               </a:ext>
             </a:extLst>
           </p:cNvPr>
@@ -5550,7 +5635,7 @@
     </p:spTree>
     <p:extLst>
       <p:ext uri="{BB962C8B-B14F-4D97-AF65-F5344CB8AC3E}">
-        <p14:creationId xmlns:p14="http://schemas.microsoft.com/office/powerpoint/2010/main" val="3225684798"/>
+        <p14:creationId xmlns:p14="http://schemas.microsoft.com/office/powerpoint/2010/main" val="3708357663"/>
       </p:ext>
     </p:extLst>
   </p:cSld>
@@ -5582,6 +5667,89 @@
           <p:cNvPr id="2" name="Title 1">
             <a:extLst>
               <a:ext uri="{FF2B5EF4-FFF2-40B4-BE49-F238E27FC236}">
+                <a16:creationId xmlns:a16="http://schemas.microsoft.com/office/drawing/2014/main" id="{D5364C91-0B81-E09B-3D40-550B812C0936}"/>
+              </a:ext>
+            </a:extLst>
+          </p:cNvPr>
+          <p:cNvSpPr>
+            <a:spLocks noGrp="1"/>
+          </p:cNvSpPr>
+          <p:nvPr>
+            <p:ph type="title"/>
+          </p:nvPr>
+        </p:nvSpPr>
+        <p:spPr/>
+        <p:txBody>
+          <a:bodyPr/>
+          <a:lstStyle/>
+          <a:p>
+            <a:r>
+              <a:rPr lang="en-US" dirty="0"/>
+              <a:t>Impact of  the new policy</a:t>
+            </a:r>
+          </a:p>
+        </p:txBody>
+      </p:sp>
+      <p:sp>
+        <p:nvSpPr>
+          <p:cNvPr id="3" name="Text Placeholder 2">
+            <a:extLst>
+              <a:ext uri="{FF2B5EF4-FFF2-40B4-BE49-F238E27FC236}">
+                <a16:creationId xmlns:a16="http://schemas.microsoft.com/office/drawing/2014/main" id="{BF1270A0-C891-F5EF-8144-0DA28B80CF05}"/>
+              </a:ext>
+            </a:extLst>
+          </p:cNvPr>
+          <p:cNvSpPr>
+            <a:spLocks noGrp="1"/>
+          </p:cNvSpPr>
+          <p:nvPr>
+            <p:ph type="body" idx="1"/>
+          </p:nvPr>
+        </p:nvSpPr>
+        <p:spPr/>
+        <p:txBody>
+          <a:bodyPr/>
+          <a:lstStyle/>
+          <a:p>
+            <a:endParaRPr lang="en-US"/>
+          </a:p>
+        </p:txBody>
+      </p:sp>
+    </p:spTree>
+    <p:extLst>
+      <p:ext uri="{BB962C8B-B14F-4D97-AF65-F5344CB8AC3E}">
+        <p14:creationId xmlns:p14="http://schemas.microsoft.com/office/powerpoint/2010/main" val="3225684798"/>
+      </p:ext>
+    </p:extLst>
+  </p:cSld>
+  <p:clrMapOvr>
+    <a:masterClrMapping/>
+  </p:clrMapOvr>
+</p:sld>
+</file>
+
+<file path=ppt/slides/slide17.xml><?xml version="1.0" encoding="utf-8"?>
+<p:sld xmlns:a="http://schemas.openxmlformats.org/drawingml/2006/main" xmlns:r="http://schemas.openxmlformats.org/officeDocument/2006/relationships" xmlns:p="http://schemas.openxmlformats.org/presentationml/2006/main">
+  <p:cSld>
+    <p:spTree>
+      <p:nvGrpSpPr>
+        <p:cNvPr id="1" name=""/>
+        <p:cNvGrpSpPr/>
+        <p:nvPr/>
+      </p:nvGrpSpPr>
+      <p:grpSpPr>
+        <a:xfrm>
+          <a:off x="0" y="0"/>
+          <a:ext cx="0" cy="0"/>
+          <a:chOff x="0" y="0"/>
+          <a:chExt cx="0" cy="0"/>
+        </a:xfrm>
+      </p:grpSpPr>
+      <p:sp>
+        <p:nvSpPr>
+          <p:cNvPr id="2" name="Title 1">
+            <a:extLst>
+              <a:ext uri="{FF2B5EF4-FFF2-40B4-BE49-F238E27FC236}">
                 <a16:creationId xmlns:a16="http://schemas.microsoft.com/office/drawing/2014/main" id="{03678344-7576-5212-4758-2F7111799A7D}"/>
               </a:ext>
             </a:extLst>
@@ -5643,7 +5811,7 @@
 </p:sld>
 </file>
 
-<file path=ppt/slides/slide17.xml><?xml version="1.0" encoding="utf-8"?>
+<file path=ppt/slides/slide18.xml><?xml version="1.0" encoding="utf-8"?>
 <p:sld xmlns:a="http://schemas.openxmlformats.org/drawingml/2006/main" xmlns:r="http://schemas.openxmlformats.org/officeDocument/2006/relationships" xmlns:p="http://schemas.openxmlformats.org/presentationml/2006/main">
   <p:cSld>
     <p:spTree>
@@ -5789,7 +5957,9 @@
         </p:nvSpPr>
         <p:spPr/>
         <p:txBody>
-          <a:bodyPr/>
+          <a:bodyPr>
+            <a:normAutofit fontScale="92500"/>
+          </a:bodyPr>
           <a:lstStyle/>
           <a:p>
             <a:r>
@@ -5802,16 +5972,82 @@
             </a:r>
           </a:p>
           <a:p>
+            <a:pPr lvl="1"/>
             <a:r>
               <a:rPr lang="en-US" baseline="0" dirty="0"/>
-              <a:t>Project Charter Overview*</a:t>
+              <a:t>Cell phones in classrooms has been a consistent concern of teachers for over a decade</a:t>
             </a:r>
           </a:p>
           <a:p>
             <a:pPr lvl="1"/>
             <a:r>
-              <a:rPr lang="en-US" dirty="0"/>
-              <a:t>Key Stakeholders*</a:t>
+              <a:rPr lang="en-US" baseline="0" dirty="0"/>
+              <a:t>As cell phones have become more advanced, they’ve also increased their ability to distract</a:t>
+            </a:r>
+          </a:p>
+          <a:p>
+            <a:pPr lvl="2"/>
+            <a:r>
+              <a:rPr lang="en-US" baseline="0" dirty="0"/>
+              <a:t>On average, students receive 273 notifications per day</a:t>
+            </a:r>
+          </a:p>
+          <a:p>
+            <a:pPr lvl="1"/>
+            <a:r>
+              <a:rPr lang="en-US" baseline="0" dirty="0"/>
+              <a:t>Recently, an </a:t>
+            </a:r>
+            <a:r>
+              <a:rPr lang="en-US" baseline="0" dirty="0" err="1"/>
+              <a:t>additieonal</a:t>
+            </a:r>
+            <a:r>
+              <a:rPr lang="en-US" baseline="0" dirty="0"/>
+              <a:t> concern with cell phones a teens, in general, has arisen</a:t>
+            </a:r>
+          </a:p>
+          <a:p>
+            <a:pPr lvl="2"/>
+            <a:r>
+              <a:rPr lang="en-US" baseline="0" dirty="0"/>
+              <a:t>Mental health consequences of phones in general</a:t>
+            </a:r>
+          </a:p>
+          <a:p>
+            <a:pPr lvl="2"/>
+            <a:r>
+              <a:rPr lang="en-US" baseline="0" dirty="0"/>
+              <a:t>If cell phones are negatively impacting student mental health, how could the permissibility of phones on campus be congruent with the greater emphasis put on mental health care.</a:t>
+            </a:r>
+          </a:p>
+          <a:p>
+            <a:pPr lvl="1"/>
+            <a:r>
+              <a:rPr lang="en-US" baseline="0" dirty="0"/>
+              <a:t>Based on most recent developments, cell phones in school has entered the zeitgeist</a:t>
+            </a:r>
+          </a:p>
+          <a:p>
+            <a:pPr lvl="2"/>
+            <a:r>
+              <a:rPr lang="en-US" baseline="0" dirty="0"/>
+              <a:t>Cell phones in schools is no </a:t>
+            </a:r>
+            <a:r>
+              <a:rPr lang="en-US" baseline="0" dirty="0" err="1"/>
+              <a:t>longersomething</a:t>
+            </a:r>
+            <a:r>
+              <a:rPr lang="en-US" baseline="0" dirty="0"/>
+              <a:t> for schools to merely tolerate, but must directly addressed. </a:t>
+            </a:r>
+          </a:p>
+          <a:p>
+            <a:pPr lvl="2"/>
+            <a:r>
+              <a:rPr lang="en-US" baseline="0" dirty="0"/>
+              <a:t>To gain a deeper understanding of this issue, I decided to perform a policy review of my school’s cell phone policy. </a:t>
             </a:r>
           </a:p>
         </p:txBody>
@@ -5851,7 +6087,7 @@
           <p:cNvPr id="2" name="Title 1">
             <a:extLst>
               <a:ext uri="{FF2B5EF4-FFF2-40B4-BE49-F238E27FC236}">
-                <a16:creationId xmlns:a16="http://schemas.microsoft.com/office/drawing/2014/main" id="{D3034F1A-CE74-DE0B-B3B2-27E7AE53B195}"/>
+                <a16:creationId xmlns:a16="http://schemas.microsoft.com/office/drawing/2014/main" id="{8B35CC7B-B2AD-FE0E-FA6C-C4553188296B}"/>
               </a:ext>
             </a:extLst>
           </p:cNvPr>
@@ -5864,48 +6100,86 @@
         </p:nvSpPr>
         <p:spPr/>
         <p:txBody>
-          <a:bodyPr>
-            <a:normAutofit fontScale="90000"/>
-          </a:bodyPr>
-          <a:lstStyle/>
-          <a:p>
+          <a:bodyPr/>
+          <a:lstStyle/>
+          <a:p>
+            <a:pPr lvl="0"/>
+            <a:r>
+              <a:rPr lang="en-US" baseline="0"/>
+              <a:t>Project Charter Overview*</a:t>
+            </a:r>
+            <a:endParaRPr lang="en-US"/>
+          </a:p>
+        </p:txBody>
+      </p:sp>
+      <p:sp>
+        <p:nvSpPr>
+          <p:cNvPr id="3" name="Content Placeholder 2">
+            <a:extLst>
+              <a:ext uri="{FF2B5EF4-FFF2-40B4-BE49-F238E27FC236}">
+                <a16:creationId xmlns:a16="http://schemas.microsoft.com/office/drawing/2014/main" id="{F4C7D4A4-7AA8-DF01-7B23-C70ADB5DFF3B}"/>
+              </a:ext>
+            </a:extLst>
+          </p:cNvPr>
+          <p:cNvSpPr>
+            <a:spLocks noGrp="1"/>
+          </p:cNvSpPr>
+          <p:nvPr>
+            <p:ph idx="1"/>
+          </p:nvPr>
+        </p:nvSpPr>
+        <p:spPr/>
+        <p:txBody>
+          <a:bodyPr/>
+          <a:lstStyle/>
+          <a:p>
+            <a:pPr lvl="0"/>
+            <a:r>
+              <a:rPr lang="en-US" baseline="0" dirty="0"/>
+              <a:t>Reason for Project: “Administrators must monitor their institution's cell phone policy and ensure it aligns with the latest educational research in furtherance of providing students with the best education.”</a:t>
+            </a:r>
+          </a:p>
+          <a:p>
+            <a:pPr lvl="0"/>
+            <a:r>
+              <a:rPr lang="en-US" baseline="0" dirty="0"/>
+              <a:t>Compare </a:t>
+            </a:r>
+            <a:r>
+              <a:rPr lang="en-US" baseline="0" dirty="0" err="1"/>
+              <a:t>LSoC’s</a:t>
+            </a:r>
+            <a:r>
+              <a:rPr lang="en-US" baseline="0" dirty="0"/>
+              <a:t> cell phone policy with peer schools. Determine if it aligns with current research.</a:t>
+            </a:r>
+          </a:p>
+          <a:p>
+            <a:pPr lvl="1"/>
+            <a:r>
+              <a:rPr lang="en-US" baseline="0" dirty="0"/>
+              <a:t>Present findings</a:t>
+            </a:r>
+          </a:p>
+          <a:p>
+            <a:pPr lvl="0"/>
             <a:r>
               <a:rPr lang="en-US" dirty="0"/>
-              <a:t>Summary of Key Elements (Scope document will be useful here)*</a:t>
-            </a:r>
-          </a:p>
-        </p:txBody>
-      </p:sp>
-      <p:sp>
-        <p:nvSpPr>
-          <p:cNvPr id="3" name="Content Placeholder 2">
-            <a:extLst>
-              <a:ext uri="{FF2B5EF4-FFF2-40B4-BE49-F238E27FC236}">
-                <a16:creationId xmlns:a16="http://schemas.microsoft.com/office/drawing/2014/main" id="{D9CAD47A-429E-4EBC-2717-A1C1F0C41687}"/>
-              </a:ext>
-            </a:extLst>
-          </p:cNvPr>
-          <p:cNvSpPr>
-            <a:spLocks noGrp="1"/>
-          </p:cNvSpPr>
-          <p:nvPr>
-            <p:ph idx="1"/>
-          </p:nvPr>
-        </p:nvSpPr>
-        <p:spPr/>
-        <p:txBody>
-          <a:bodyPr/>
-          <a:lstStyle/>
-          <a:p>
+              <a:t>Key Stakeholders</a:t>
+            </a:r>
+          </a:p>
+          <a:p>
+            <a:pPr lvl="1"/>
             <a:r>
               <a:rPr lang="en-US" dirty="0"/>
-              <a:t>The Aim of the Project</a:t>
-            </a:r>
-          </a:p>
-          <a:p>
+              <a:t>On site supervisor: Karen Horvath</a:t>
+            </a:r>
+          </a:p>
+          <a:p>
+            <a:pPr lvl="1"/>
             <a:r>
               <a:rPr lang="en-US" dirty="0"/>
-              <a:t>What data was used</a:t>
+              <a:t>Stakeholders: Entire school community</a:t>
             </a:r>
           </a:p>
         </p:txBody>
@@ -5913,7 +6187,7 @@
     </p:spTree>
     <p:extLst>
       <p:ext uri="{BB962C8B-B14F-4D97-AF65-F5344CB8AC3E}">
-        <p14:creationId xmlns:p14="http://schemas.microsoft.com/office/powerpoint/2010/main" val="1545784350"/>
+        <p14:creationId xmlns:p14="http://schemas.microsoft.com/office/powerpoint/2010/main" val="1179628333"/>
       </p:ext>
     </p:extLst>
   </p:cSld>
@@ -5945,7 +6219,7 @@
           <p:cNvPr id="2" name="Title 1">
             <a:extLst>
               <a:ext uri="{FF2B5EF4-FFF2-40B4-BE49-F238E27FC236}">
-                <a16:creationId xmlns:a16="http://schemas.microsoft.com/office/drawing/2014/main" id="{25981601-674C-7AA3-87D8-44396FF51532}"/>
+                <a16:creationId xmlns:a16="http://schemas.microsoft.com/office/drawing/2014/main" id="{D3034F1A-CE74-DE0B-B3B2-27E7AE53B195}"/>
               </a:ext>
             </a:extLst>
           </p:cNvPr>
@@ -5958,53 +6232,114 @@
         </p:nvSpPr>
         <p:spPr/>
         <p:txBody>
-          <a:bodyPr/>
-          <a:lstStyle/>
+          <a:bodyPr>
+            <a:normAutofit fontScale="90000"/>
+          </a:bodyPr>
+          <a:lstStyle/>
+          <a:p>
+            <a:r>
+              <a:rPr lang="en-US" dirty="0"/>
+              <a:t>Summary of Key Elements (Scope document will be useful here)*</a:t>
+            </a:r>
+          </a:p>
+        </p:txBody>
+      </p:sp>
+      <p:sp>
+        <p:nvSpPr>
+          <p:cNvPr id="3" name="Content Placeholder 2">
+            <a:extLst>
+              <a:ext uri="{FF2B5EF4-FFF2-40B4-BE49-F238E27FC236}">
+                <a16:creationId xmlns:a16="http://schemas.microsoft.com/office/drawing/2014/main" id="{D9CAD47A-429E-4EBC-2717-A1C1F0C41687}"/>
+              </a:ext>
+            </a:extLst>
+          </p:cNvPr>
+          <p:cNvSpPr>
+            <a:spLocks noGrp="1"/>
+          </p:cNvSpPr>
+          <p:nvPr>
+            <p:ph idx="1"/>
+          </p:nvPr>
+        </p:nvSpPr>
+        <p:spPr/>
+        <p:txBody>
+          <a:bodyPr>
+            <a:normAutofit fontScale="92500" lnSpcReduction="20000"/>
+          </a:bodyPr>
+          <a:lstStyle/>
+          <a:p>
+            <a:r>
+              <a:rPr lang="en-US" dirty="0"/>
+              <a:t>The Aim of the Project</a:t>
+            </a:r>
+          </a:p>
+          <a:p>
+            <a:pPr lvl="1"/>
+            <a:r>
+              <a:rPr lang="en-US" dirty="0"/>
+              <a:t>“Create a 5-7 minute PowerPoint presentation that reviews the Latin School of Chicago’s cell phone policy, its impacts, and how it aligns with the latest research and best practices in the education field.”</a:t>
+            </a:r>
+          </a:p>
+          <a:p>
+            <a:r>
+              <a:rPr lang="en-US" dirty="0"/>
+              <a:t>What data was used</a:t>
+            </a:r>
+          </a:p>
+          <a:p>
+            <a:pPr lvl="1"/>
+            <a:r>
+              <a:rPr lang="en-US" dirty="0"/>
+              <a:t>Two on-site cell phone surveys</a:t>
+            </a:r>
+          </a:p>
           <a:p>
             <a:pPr lvl="0"/>
             <a:r>
               <a:rPr lang="en-US" dirty="0"/>
-              <a:t>What were the measures of success?*</a:t>
-            </a:r>
-          </a:p>
-        </p:txBody>
-      </p:sp>
-      <p:sp>
-        <p:nvSpPr>
-          <p:cNvPr id="3" name="Content Placeholder 2">
-            <a:extLst>
-              <a:ext uri="{FF2B5EF4-FFF2-40B4-BE49-F238E27FC236}">
-                <a16:creationId xmlns:a16="http://schemas.microsoft.com/office/drawing/2014/main" id="{BFD0A69D-2B16-DC9E-2870-A97C28D55E10}"/>
-              </a:ext>
-            </a:extLst>
-          </p:cNvPr>
-          <p:cNvSpPr>
-            <a:spLocks noGrp="1"/>
-          </p:cNvSpPr>
-          <p:nvPr>
-            <p:ph idx="1"/>
-          </p:nvPr>
-        </p:nvSpPr>
-        <p:spPr/>
-        <p:txBody>
-          <a:bodyPr/>
-          <a:lstStyle/>
-          <a:p>
+              <a:t>Out of scope: </a:t>
+            </a:r>
+          </a:p>
+          <a:p>
+            <a:pPr lvl="1"/>
             <a:r>
               <a:rPr lang="en-US" dirty="0"/>
-              <a:t>What data was used to define project focus?</a:t>
-            </a:r>
-          </a:p>
-          <a:p>
+              <a:t>No effort</a:t>
+            </a:r>
+            <a:r>
+              <a:rPr lang="en-US" baseline="0" dirty="0"/>
+              <a:t> to change any internal policies</a:t>
+            </a:r>
+          </a:p>
+          <a:p>
+            <a:pPr lvl="1"/>
             <a:r>
               <a:rPr lang="en-US" dirty="0"/>
-              <a:t>What data was used to measure progress?</a:t>
-            </a:r>
-          </a:p>
-          <a:p>
+              <a:t>Input or support from senior leadership, US leadership would provide limited support</a:t>
+            </a:r>
+          </a:p>
+          <a:p>
+            <a:pPr lvl="0"/>
             <a:r>
               <a:rPr lang="en-US" dirty="0"/>
-              <a:t>What data was used to provide evidence of success?</a:t>
+              <a:t>Constraints</a:t>
+            </a:r>
+          </a:p>
+          <a:p>
+            <a:pPr lvl="1"/>
+            <a:r>
+              <a:rPr lang="en-US" dirty="0"/>
+              <a:t>Only one faculty survey</a:t>
+            </a:r>
+            <a:r>
+              <a:rPr lang="en-US" baseline="0" dirty="0"/>
+              <a:t> permitted per school year</a:t>
+            </a:r>
+          </a:p>
+          <a:p>
+            <a:pPr lvl="1"/>
+            <a:r>
+              <a:rPr lang="en-US" dirty="0"/>
+              <a:t>Access to other school’s information may be limited</a:t>
             </a:r>
           </a:p>
         </p:txBody>
@@ -6012,7 +6347,7 @@
     </p:spTree>
     <p:extLst>
       <p:ext uri="{BB962C8B-B14F-4D97-AF65-F5344CB8AC3E}">
-        <p14:creationId xmlns:p14="http://schemas.microsoft.com/office/powerpoint/2010/main" val="4161786951"/>
+        <p14:creationId xmlns:p14="http://schemas.microsoft.com/office/powerpoint/2010/main" val="1545784350"/>
       </p:ext>
     </p:extLst>
   </p:cSld>
@@ -6044,7 +6379,7 @@
           <p:cNvPr id="2" name="Title 1">
             <a:extLst>
               <a:ext uri="{FF2B5EF4-FFF2-40B4-BE49-F238E27FC236}">
-                <a16:creationId xmlns:a16="http://schemas.microsoft.com/office/drawing/2014/main" id="{8259D4FB-7D6D-124A-81DF-B08D0E3BA58E}"/>
+                <a16:creationId xmlns:a16="http://schemas.microsoft.com/office/drawing/2014/main" id="{25981601-674C-7AA3-87D8-44396FF51532}"/>
               </a:ext>
             </a:extLst>
           </p:cNvPr>
@@ -6057,52 +6392,86 @@
         </p:nvSpPr>
         <p:spPr/>
         <p:txBody>
-          <a:bodyPr>
-            <a:normAutofit fontScale="90000"/>
-          </a:bodyPr>
-          <a:lstStyle/>
-          <a:p>
+          <a:bodyPr/>
+          <a:lstStyle/>
+          <a:p>
+            <a:pPr lvl="0"/>
             <a:r>
               <a:rPr lang="en-US" dirty="0"/>
-              <a:t>What</a:t>
+              <a:t>What were the measures of success?*</a:t>
+            </a:r>
+          </a:p>
+        </p:txBody>
+      </p:sp>
+      <p:sp>
+        <p:nvSpPr>
+          <p:cNvPr id="3" name="Content Placeholder 2">
+            <a:extLst>
+              <a:ext uri="{FF2B5EF4-FFF2-40B4-BE49-F238E27FC236}">
+                <a16:creationId xmlns:a16="http://schemas.microsoft.com/office/drawing/2014/main" id="{BFD0A69D-2B16-DC9E-2870-A97C28D55E10}"/>
+              </a:ext>
+            </a:extLst>
+          </p:cNvPr>
+          <p:cNvSpPr>
+            <a:spLocks noGrp="1"/>
+          </p:cNvSpPr>
+          <p:nvPr>
+            <p:ph idx="1"/>
+          </p:nvPr>
+        </p:nvSpPr>
+        <p:spPr/>
+        <p:txBody>
+          <a:bodyPr/>
+          <a:lstStyle/>
+          <a:p>
+            <a:r>
+              <a:rPr lang="en-US" dirty="0"/>
+              <a:t>What data was used to define project focus?</a:t>
+            </a:r>
+          </a:p>
+          <a:p>
+            <a:r>
+              <a:rPr lang="en-US" dirty="0"/>
+              <a:t>What data was used to measure progress?</a:t>
+            </a:r>
+          </a:p>
+          <a:p>
+            <a:r>
+              <a:rPr lang="en-US" dirty="0"/>
+              <a:t>What data was used to provide evidence of success?</a:t>
+            </a:r>
+          </a:p>
+          <a:p>
+            <a:r>
+              <a:rPr lang="en-US" dirty="0"/>
+              <a:t>Success in this project was</a:t>
             </a:r>
             <a:r>
               <a:rPr lang="en-US" baseline="0" dirty="0"/>
-              <a:t> changes were made from beginning to end of project?*</a:t>
-            </a:r>
-            <a:endParaRPr lang="en-US" dirty="0"/>
-          </a:p>
-        </p:txBody>
-      </p:sp>
-      <p:sp>
-        <p:nvSpPr>
-          <p:cNvPr id="3" name="Content Placeholder 2">
-            <a:extLst>
-              <a:ext uri="{FF2B5EF4-FFF2-40B4-BE49-F238E27FC236}">
-                <a16:creationId xmlns:a16="http://schemas.microsoft.com/office/drawing/2014/main" id="{880D4F19-6BB3-AB29-5561-C59C7CEEA74E}"/>
-              </a:ext>
-            </a:extLst>
-          </p:cNvPr>
-          <p:cNvSpPr>
-            <a:spLocks noGrp="1"/>
-          </p:cNvSpPr>
-          <p:nvPr>
-            <p:ph idx="1"/>
-          </p:nvPr>
-        </p:nvSpPr>
-        <p:spPr/>
-        <p:txBody>
-          <a:bodyPr/>
-          <a:lstStyle/>
-          <a:p>
-            <a:endParaRPr lang="en-US"/>
+              <a:t> to perform a comprehensive, holistic analysis and present it to stakeholders</a:t>
+            </a:r>
+          </a:p>
+          <a:p>
+            <a:pPr lvl="1"/>
+            <a:r>
+              <a:rPr lang="en-US" dirty="0"/>
+              <a:t>Latin’s policy, examine its impacts, and express </a:t>
+            </a:r>
+            <a:r>
+              <a:rPr lang="en-US" dirty="0" err="1"/>
+              <a:t>facultys</a:t>
+            </a:r>
+            <a:r>
+              <a:rPr lang="en-US" dirty="0"/>
+              <a:t> perspective on the issue. Also must contrast with best practices and at least one other school.</a:t>
+            </a:r>
           </a:p>
         </p:txBody>
       </p:sp>
     </p:spTree>
     <p:extLst>
       <p:ext uri="{BB962C8B-B14F-4D97-AF65-F5344CB8AC3E}">
-        <p14:creationId xmlns:p14="http://schemas.microsoft.com/office/powerpoint/2010/main" val="3562138366"/>
+        <p14:creationId xmlns:p14="http://schemas.microsoft.com/office/powerpoint/2010/main" val="4161786951"/>
       </p:ext>
     </p:extLst>
   </p:cSld>
@@ -6134,7 +6503,7 @@
           <p:cNvPr id="2" name="Title 1">
             <a:extLst>
               <a:ext uri="{FF2B5EF4-FFF2-40B4-BE49-F238E27FC236}">
-                <a16:creationId xmlns:a16="http://schemas.microsoft.com/office/drawing/2014/main" id="{22B95E29-A760-46D9-2295-F1F8A4FC9F09}"/>
+                <a16:creationId xmlns:a16="http://schemas.microsoft.com/office/drawing/2014/main" id="{8259D4FB-7D6D-124A-81DF-B08D0E3BA58E}"/>
               </a:ext>
             </a:extLst>
           </p:cNvPr>
@@ -6154,8 +6523,13 @@
           <a:p>
             <a:r>
               <a:rPr lang="en-US" dirty="0"/>
-              <a:t>How did your project interface with school culture, character education, and/or ethical practice?*</a:t>
-            </a:r>
+              <a:t>What</a:t>
+            </a:r>
+            <a:r>
+              <a:rPr lang="en-US" baseline="0" dirty="0"/>
+              <a:t> changes were made from beginning to end of project?*</a:t>
+            </a:r>
+            <a:endParaRPr lang="en-US" dirty="0"/>
           </a:p>
         </p:txBody>
       </p:sp>
@@ -6164,7 +6538,7 @@
           <p:cNvPr id="3" name="Content Placeholder 2">
             <a:extLst>
               <a:ext uri="{FF2B5EF4-FFF2-40B4-BE49-F238E27FC236}">
-                <a16:creationId xmlns:a16="http://schemas.microsoft.com/office/drawing/2014/main" id="{94748BC5-3353-49BA-4DA3-0FECDA8EE552}"/>
+                <a16:creationId xmlns:a16="http://schemas.microsoft.com/office/drawing/2014/main" id="{880D4F19-6BB3-AB29-5561-C59C7CEEA74E}"/>
               </a:ext>
             </a:extLst>
           </p:cNvPr>
@@ -6180,14 +6554,35 @@
           <a:bodyPr/>
           <a:lstStyle/>
           <a:p>
-            <a:endParaRPr lang="en-US"/>
+            <a:r>
+              <a:rPr lang="en-US" dirty="0"/>
+              <a:t>Caught by surprise:</a:t>
+            </a:r>
+          </a:p>
+          <a:p>
+            <a:pPr lvl="1"/>
+            <a:r>
+              <a:rPr lang="en-US" dirty="0"/>
+              <a:t>Latin</a:t>
+            </a:r>
+            <a:r>
+              <a:rPr lang="en-US" baseline="0" dirty="0"/>
+              <a:t> decides, independently, to create a new cell phone policy in the midst of the project</a:t>
+            </a:r>
+          </a:p>
+          <a:p>
+            <a:pPr lvl="2"/>
+            <a:r>
+              <a:rPr lang="en-US" dirty="0"/>
+              <a:t>Positive benefit to the project, as it opened the door to A-B testing of our on-site policy</a:t>
+            </a:r>
           </a:p>
         </p:txBody>
       </p:sp>
     </p:spTree>
     <p:extLst>
       <p:ext uri="{BB962C8B-B14F-4D97-AF65-F5344CB8AC3E}">
-        <p14:creationId xmlns:p14="http://schemas.microsoft.com/office/powerpoint/2010/main" val="1607239339"/>
+        <p14:creationId xmlns:p14="http://schemas.microsoft.com/office/powerpoint/2010/main" val="3562138366"/>
       </p:ext>
     </p:extLst>
   </p:cSld>
@@ -6219,7 +6614,7 @@
           <p:cNvPr id="2" name="Title 1">
             <a:extLst>
               <a:ext uri="{FF2B5EF4-FFF2-40B4-BE49-F238E27FC236}">
-                <a16:creationId xmlns:a16="http://schemas.microsoft.com/office/drawing/2014/main" id="{A7188CBA-5D1E-AFB6-EC2A-C6024D1C2619}"/>
+                <a16:creationId xmlns:a16="http://schemas.microsoft.com/office/drawing/2014/main" id="{22B95E29-A760-46D9-2295-F1F8A4FC9F09}"/>
               </a:ext>
             </a:extLst>
           </p:cNvPr>
@@ -6239,7 +6634,7 @@
           <a:p>
             <a:r>
               <a:rPr lang="en-US" dirty="0"/>
-              <a:t>What was the impact of project and what data was used as evidence of impact?*</a:t>
+              <a:t>How did your project interface with school culture, character education, and/or ethical practice?*</a:t>
             </a:r>
           </a:p>
         </p:txBody>
@@ -6249,7 +6644,7 @@
           <p:cNvPr id="3" name="Content Placeholder 2">
             <a:extLst>
               <a:ext uri="{FF2B5EF4-FFF2-40B4-BE49-F238E27FC236}">
-                <a16:creationId xmlns:a16="http://schemas.microsoft.com/office/drawing/2014/main" id="{B04ED208-6FDE-59EC-749C-5ADE5FD21ECB}"/>
+                <a16:creationId xmlns:a16="http://schemas.microsoft.com/office/drawing/2014/main" id="{94748BC5-3353-49BA-4DA3-0FECDA8EE552}"/>
               </a:ext>
             </a:extLst>
           </p:cNvPr>
@@ -6265,14 +6660,54 @@
           <a:bodyPr/>
           <a:lstStyle/>
           <a:p>
-            <a:endParaRPr lang="en-US"/>
+            <a:r>
+              <a:rPr lang="en-US" dirty="0"/>
+              <a:t>My project interfaced with the school culture</a:t>
+            </a:r>
+            <a:r>
+              <a:rPr lang="en-US" baseline="0" dirty="0"/>
+              <a:t> strongly</a:t>
+            </a:r>
+          </a:p>
+          <a:p>
+            <a:pPr lvl="1"/>
+            <a:r>
+              <a:rPr lang="en-US" dirty="0"/>
+              <a:t>At the time of starting my project, the cell phone problem was a frequent topic of conversation with faculty</a:t>
+            </a:r>
+          </a:p>
+          <a:p>
+            <a:pPr lvl="2"/>
+            <a:r>
+              <a:rPr lang="en-US" dirty="0"/>
+              <a:t>And a source of frustration</a:t>
+            </a:r>
+          </a:p>
+          <a:p>
+            <a:pPr lvl="2"/>
+            <a:r>
+              <a:rPr lang="en-US" dirty="0"/>
+              <a:t>So this integrated with the school culture of excellence</a:t>
+            </a:r>
+          </a:p>
+          <a:p>
+            <a:pPr lvl="3"/>
+            <a:r>
+              <a:rPr lang="en-US" dirty="0"/>
+              <a:t>How could we providing</a:t>
+            </a:r>
+            <a:r>
+              <a:rPr lang="en-US" baseline="0" dirty="0"/>
+              <a:t> excellence with a distracted student population</a:t>
+            </a:r>
+            <a:endParaRPr lang="en-US" dirty="0"/>
           </a:p>
         </p:txBody>
       </p:sp>
     </p:spTree>
     <p:extLst>
       <p:ext uri="{BB962C8B-B14F-4D97-AF65-F5344CB8AC3E}">
-        <p14:creationId xmlns:p14="http://schemas.microsoft.com/office/powerpoint/2010/main" val="1336174748"/>
+        <p14:creationId xmlns:p14="http://schemas.microsoft.com/office/powerpoint/2010/main" val="1607239339"/>
       </p:ext>
     </p:extLst>
   </p:cSld>
@@ -6304,7 +6739,7 @@
           <p:cNvPr id="2" name="Title 1">
             <a:extLst>
               <a:ext uri="{FF2B5EF4-FFF2-40B4-BE49-F238E27FC236}">
-                <a16:creationId xmlns:a16="http://schemas.microsoft.com/office/drawing/2014/main" id="{CD1830F7-ED3F-649E-4794-1EAE66D5A58B}"/>
+                <a16:creationId xmlns:a16="http://schemas.microsoft.com/office/drawing/2014/main" id="{A7188CBA-5D1E-AFB6-EC2A-C6024D1C2619}"/>
               </a:ext>
             </a:extLst>
           </p:cNvPr>
@@ -6324,7 +6759,7 @@
           <a:p>
             <a:r>
               <a:rPr lang="en-US" dirty="0"/>
-              <a:t>What are the next steps for this project; is it ongoing or is it at completion?  Where will you/would you take it next if you were to continue to work on this issue and why?*</a:t>
+              <a:t>What was the impact of project and what data was used as evidence of impact?*</a:t>
             </a:r>
           </a:p>
         </p:txBody>
@@ -6334,7 +6769,7 @@
           <p:cNvPr id="3" name="Content Placeholder 2">
             <a:extLst>
               <a:ext uri="{FF2B5EF4-FFF2-40B4-BE49-F238E27FC236}">
-                <a16:creationId xmlns:a16="http://schemas.microsoft.com/office/drawing/2014/main" id="{38487020-4137-F6C5-BBB9-5829EA02FDCD}"/>
+                <a16:creationId xmlns:a16="http://schemas.microsoft.com/office/drawing/2014/main" id="{B04ED208-6FDE-59EC-749C-5ADE5FD21ECB}"/>
               </a:ext>
             </a:extLst>
           </p:cNvPr>
@@ -6347,17 +6782,108 @@
         </p:nvSpPr>
         <p:spPr/>
         <p:txBody>
-          <a:bodyPr/>
-          <a:lstStyle/>
-          <a:p>
-            <a:endParaRPr lang="en-US"/>
+          <a:bodyPr>
+            <a:normAutofit fontScale="92500" lnSpcReduction="10000"/>
+          </a:bodyPr>
+          <a:lstStyle/>
+          <a:p>
+            <a:r>
+              <a:rPr lang="en-US" dirty="0"/>
+              <a:t>The impact of this project was to provide</a:t>
+            </a:r>
+            <a:r>
+              <a:rPr lang="en-US" baseline="0" dirty="0"/>
+              <a:t> fellow faculty and administrators with a wider view of the cell phone policy, provide </a:t>
+            </a:r>
+            <a:r>
+              <a:rPr lang="en-US" baseline="0" dirty="0" err="1"/>
+              <a:t>administraters</a:t>
+            </a:r>
+            <a:r>
+              <a:rPr lang="en-US" baseline="0" dirty="0"/>
+              <a:t> with hard data that they could add to tier analysis and reflection on the new policy</a:t>
+            </a:r>
+          </a:p>
+          <a:p>
+            <a:r>
+              <a:rPr lang="en-US" baseline="0" dirty="0"/>
+              <a:t>It is one thing to make a policy decision, another to evaluate its performance and to iterate and improve</a:t>
+            </a:r>
+          </a:p>
+          <a:p>
+            <a:r>
+              <a:rPr lang="en-US" baseline="0" dirty="0"/>
+              <a:t>As far as I know, there was not any other feedback mechanism built into this new policy besides anecdotal reports to administration</a:t>
+            </a:r>
+          </a:p>
+          <a:p>
+            <a:pPr lvl="1"/>
+            <a:r>
+              <a:rPr lang="en-US" dirty="0"/>
+              <a:t>This would have been flawed because perhaps</a:t>
+            </a:r>
+            <a:r>
+              <a:rPr lang="en-US" baseline="0" dirty="0"/>
+              <a:t> important feedback could go missing merely because who are the faculty that frequently talk with administrators?</a:t>
+            </a:r>
+          </a:p>
+          <a:p>
+            <a:pPr lvl="0"/>
+            <a:r>
+              <a:rPr lang="en-US" dirty="0"/>
+              <a:t>Data that is evidence of the project’s impact is that I was invited to present to</a:t>
+            </a:r>
+            <a:r>
+              <a:rPr lang="en-US" baseline="0" dirty="0"/>
+              <a:t> every</a:t>
+            </a:r>
+            <a:r>
+              <a:rPr lang="en-US" sz="2000" kern="1200" baseline="0" dirty="0">
+                <a:solidFill>
+                  <a:schemeClr val="tx1"/>
+                </a:solidFill>
+                <a:effectLst/>
+                <a:latin typeface="+mn-lt"/>
+                <a:ea typeface="+mn-ea"/>
+                <a:cs typeface="+mn-cs"/>
+              </a:rPr>
+              <a:t>one in a faculty meeting – this recognized the importance </a:t>
+            </a:r>
+            <a:r>
+              <a:rPr lang="en-US" sz="2000" kern="1200" baseline="0" dirty="0" err="1">
+                <a:solidFill>
+                  <a:schemeClr val="tx1"/>
+                </a:solidFill>
+                <a:effectLst/>
+                <a:latin typeface="+mn-lt"/>
+                <a:ea typeface="+mn-ea"/>
+                <a:cs typeface="+mn-cs"/>
+              </a:rPr>
+              <a:t>ofe</a:t>
+            </a:r>
+            <a:r>
+              <a:rPr lang="en-US" sz="2000" kern="1200" baseline="0" dirty="0">
+                <a:solidFill>
+                  <a:schemeClr val="tx1"/>
+                </a:solidFill>
+                <a:effectLst/>
+                <a:latin typeface="+mn-lt"/>
+                <a:ea typeface="+mn-ea"/>
+                <a:cs typeface="+mn-cs"/>
+              </a:rPr>
+              <a:t> gathering this info</a:t>
+            </a:r>
+            <a:r>
+              <a:rPr lang="en-US" dirty="0"/>
+              <a:t> </a:t>
+            </a:r>
           </a:p>
         </p:txBody>
       </p:sp>
     </p:spTree>
     <p:extLst>
       <p:ext uri="{BB962C8B-B14F-4D97-AF65-F5344CB8AC3E}">
-        <p14:creationId xmlns:p14="http://schemas.microsoft.com/office/powerpoint/2010/main" val="1688785539"/>
+        <p14:creationId xmlns:p14="http://schemas.microsoft.com/office/powerpoint/2010/main" val="1336174748"/>
       </p:ext>
     </p:extLst>
   </p:cSld>
@@ -6389,7 +6915,7 @@
           <p:cNvPr id="2" name="Title 1">
             <a:extLst>
               <a:ext uri="{FF2B5EF4-FFF2-40B4-BE49-F238E27FC236}">
-                <a16:creationId xmlns:a16="http://schemas.microsoft.com/office/drawing/2014/main" id="{E969534C-CACF-5359-A628-373C2B981F33}"/>
+                <a16:creationId xmlns:a16="http://schemas.microsoft.com/office/drawing/2014/main" id="{CD1830F7-ED3F-649E-4794-1EAE66D5A58B}"/>
               </a:ext>
             </a:extLst>
           </p:cNvPr>
@@ -6402,45 +6928,144 @@
         </p:nvSpPr>
         <p:spPr/>
         <p:txBody>
-          <a:bodyPr/>
+          <a:bodyPr>
+            <a:normAutofit fontScale="90000"/>
+          </a:bodyPr>
           <a:lstStyle/>
           <a:p>
             <a:r>
               <a:rPr lang="en-US" dirty="0"/>
-              <a:t>The Issue</a:t>
-            </a:r>
-          </a:p>
-        </p:txBody>
-      </p:sp>
-      <p:sp>
-        <p:nvSpPr>
-          <p:cNvPr id="3" name="Text Placeholder 2">
-            <a:extLst>
-              <a:ext uri="{FF2B5EF4-FFF2-40B4-BE49-F238E27FC236}">
-                <a16:creationId xmlns:a16="http://schemas.microsoft.com/office/drawing/2014/main" id="{7C1838AA-32EF-5619-0D4F-E448665BCF5B}"/>
-              </a:ext>
-            </a:extLst>
-          </p:cNvPr>
-          <p:cNvSpPr>
-            <a:spLocks noGrp="1"/>
-          </p:cNvSpPr>
-          <p:nvPr>
-            <p:ph type="body" idx="1"/>
-          </p:nvPr>
-        </p:nvSpPr>
-        <p:spPr/>
-        <p:txBody>
-          <a:bodyPr/>
-          <a:lstStyle/>
-          <a:p>
-            <a:endParaRPr lang="en-US"/>
+              <a:t>What are the next steps for this project; is it ongoing or is it at completion?  Where will you/would you take it next if you were to continue to work on this issue and why?*</a:t>
+            </a:r>
+          </a:p>
+        </p:txBody>
+      </p:sp>
+      <p:sp>
+        <p:nvSpPr>
+          <p:cNvPr id="3" name="Content Placeholder 2">
+            <a:extLst>
+              <a:ext uri="{FF2B5EF4-FFF2-40B4-BE49-F238E27FC236}">
+                <a16:creationId xmlns:a16="http://schemas.microsoft.com/office/drawing/2014/main" id="{38487020-4137-F6C5-BBB9-5829EA02FDCD}"/>
+              </a:ext>
+            </a:extLst>
+          </p:cNvPr>
+          <p:cNvSpPr>
+            <a:spLocks noGrp="1"/>
+          </p:cNvSpPr>
+          <p:nvPr>
+            <p:ph idx="1"/>
+          </p:nvPr>
+        </p:nvSpPr>
+        <p:spPr/>
+        <p:txBody>
+          <a:bodyPr>
+            <a:normAutofit fontScale="70000" lnSpcReduction="20000"/>
+          </a:bodyPr>
+          <a:lstStyle/>
+          <a:p>
+            <a:r>
+              <a:rPr lang="en-US" dirty="0"/>
+              <a:t>The next steps for this project is to </a:t>
+            </a:r>
+            <a:r>
+              <a:rPr lang="en-US" dirty="0" err="1"/>
+              <a:t>exapand</a:t>
+            </a:r>
+            <a:r>
+              <a:rPr lang="en-US" baseline="0" dirty="0"/>
+              <a:t> it. I</a:t>
+            </a:r>
+          </a:p>
+          <a:p>
+            <a:r>
+              <a:rPr lang="en-US" baseline="0" dirty="0"/>
+              <a:t>I have built a budding expertise of technology policies in schools</a:t>
+            </a:r>
+          </a:p>
+          <a:p>
+            <a:r>
+              <a:rPr lang="en-US" baseline="0" dirty="0"/>
+              <a:t>I hope to expand my reach in AI policy</a:t>
+            </a:r>
+          </a:p>
+          <a:p>
+            <a:r>
+              <a:rPr lang="en-US" baseline="0" dirty="0"/>
+              <a:t>Based on my experience and observations, I am eager to bring a forward-thinking and data-informed approach to school technology policies. </a:t>
+            </a:r>
+          </a:p>
+          <a:p>
+            <a:pPr lvl="1"/>
+            <a:r>
+              <a:rPr lang="en-US" dirty="0"/>
+              <a:t>Through this experience I have discovered the importance of data collection and data-driven decision making</a:t>
+            </a:r>
+          </a:p>
+          <a:p>
+            <a:pPr lvl="1"/>
+            <a:r>
+              <a:rPr lang="en-US" dirty="0"/>
+              <a:t>I have also discovered the challenge of collecting information that will yield actionable</a:t>
+            </a:r>
+            <a:r>
+              <a:rPr lang="en-US" baseline="0" dirty="0"/>
+              <a:t> </a:t>
+            </a:r>
+            <a:r>
+              <a:rPr lang="en-US" dirty="0"/>
+              <a:t>insight</a:t>
+            </a:r>
+          </a:p>
+          <a:p>
+            <a:pPr lvl="0"/>
+            <a:r>
+              <a:rPr lang="en-US" dirty="0"/>
+              <a:t>I hope to find work as an educational administrator at schools that put educational technology at the forefront,</a:t>
+            </a:r>
+            <a:r>
+              <a:rPr lang="en-US" baseline="0" dirty="0"/>
+              <a:t> and also must grapple with the impediments that technology may impose</a:t>
+            </a:r>
+          </a:p>
+          <a:p>
+            <a:pPr lvl="0"/>
+            <a:r>
+              <a:rPr lang="en-US" baseline="0" dirty="0"/>
+              <a:t>My expertise and background in computer science inform my understanding and vision for school policies that go even further</a:t>
+            </a:r>
+          </a:p>
+          <a:p>
+            <a:pPr lvl="1"/>
+            <a:r>
+              <a:rPr lang="en-US" dirty="0"/>
+              <a:t>For example, schools need to be more strict in allowed devices (with special exceptions [computer labs])</a:t>
+            </a:r>
+          </a:p>
+          <a:p>
+            <a:pPr lvl="1"/>
+            <a:r>
+              <a:rPr lang="en-US" dirty="0"/>
+              <a:t>Schools should only allow digital devices that they control into the classroom</a:t>
+            </a:r>
+          </a:p>
+          <a:p>
+            <a:pPr lvl="2"/>
+            <a:r>
+              <a:rPr lang="en-US" dirty="0"/>
+              <a:t>In the surveys, it was brought up – are we just passing on this issue to other devices – smart watches?</a:t>
+            </a:r>
+            <a:r>
+              <a:rPr lang="en-US" baseline="0" dirty="0"/>
+              <a:t> iMessage?</a:t>
+            </a:r>
+            <a:endParaRPr lang="en-US" dirty="0"/>
           </a:p>
         </p:txBody>
       </p:sp>
     </p:spTree>
     <p:extLst>
       <p:ext uri="{BB962C8B-B14F-4D97-AF65-F5344CB8AC3E}">
-        <p14:creationId xmlns:p14="http://schemas.microsoft.com/office/powerpoint/2010/main" val="2798690559"/>
+        <p14:creationId xmlns:p14="http://schemas.microsoft.com/office/powerpoint/2010/main" val="1688785539"/>
       </p:ext>
     </p:extLst>
   </p:cSld>

</xml_diff>